<commit_message>
atualizado comentários em Análise de Desempenho da Proteção
</commit_message>
<xml_diff>
--- a/MODELO PPT/ANA AT XXX-26 - AAA BBBB - 01.04.2026.pptx
+++ b/MODELO PPT/ANA AT XXX-26 - AAA BBBB - 01.04.2026.pptx
@@ -235,7 +235,7 @@
           <a:p>
             <a:fld id="{D75075BA-4AC8-4657-B5DF-53A580E4AB38}" type="datetimeFigureOut">
               <a:rPr lang="pt-BR" smtClean="0"/>
-              <a:t>06/04/2026</a:t>
+              <a:t>07/04/2026</a:t>
             </a:fld>
             <a:endParaRPr lang="pt-BR"/>
           </a:p>
@@ -400,7 +400,7 @@
           <a:p>
             <a:fld id="{AB1EB865-99EF-48F5-8834-496CACB86A0F}" type="datetimeFigureOut">
               <a:rPr lang="pt-BR" smtClean="0"/>
-              <a:t>06/04/2026</a:t>
+              <a:t>07/04/2026</a:t>
             </a:fld>
             <a:endParaRPr lang="pt-BR"/>
           </a:p>
@@ -3144,19 +3144,103 @@
               <a:buFont typeface="Wingdings" panose="05000000000000000000" pitchFamily="2" charset="2"/>
               <a:buChar char="q"/>
             </a:pPr>
-            <a:endParaRPr lang="pt-BR" sz="1400" dirty="0">
-              <a:solidFill>
-                <a:schemeClr val="bg1"/>
-              </a:solidFill>
-              <a:latin typeface="Aptos" panose="020B0004020202020204" pitchFamily="34" charset="0"/>
-            </a:endParaRPr>
+            <a:r>
+              <a:rPr lang="pt-BR" sz="1400" dirty="0">
+                <a:solidFill>
+                  <a:srgbClr val="000000"/>
+                </a:solidFill>
+                <a:latin typeface="Aptos"/>
+              </a:rPr>
+              <a:t>Na ocorrência em análise, o disjuntor NZA 12M7 registrou um evento do tipo fase-terra, com corrente de falta de 235.98 A e disparo da função 51N1T às 16:06:10.817;</a:t>
+            </a:r>
           </a:p>
           <a:p>
             <a:pPr marL="285750" indent="-285750" algn="just">
               <a:buFont typeface="Wingdings" panose="05000000000000000000" pitchFamily="2" charset="2"/>
               <a:buChar char="q"/>
             </a:pPr>
-            <a:endParaRPr lang="pt-BR" sz="1400" dirty="0">
+            <a:r>
+              <a:rPr lang="pt-BR" sz="1400" dirty="0">
+                <a:solidFill>
+                  <a:srgbClr val="000000"/>
+                </a:solidFill>
+                <a:latin typeface="Aptos"/>
+              </a:rPr>
+              <a:t>No SER, observa-se a sensibilização inicial em 16:06:08.005, resultando em tempo real de atuação de 2812 </a:t>
+            </a:r>
+            <a:r>
+              <a:rPr lang="pt-BR" sz="1400" dirty="0" err="1">
+                <a:solidFill>
+                  <a:srgbClr val="000000"/>
+                </a:solidFill>
+                <a:latin typeface="Aptos"/>
+              </a:rPr>
+              <a:t>ms</a:t>
+            </a:r>
+            <a:r>
+              <a:rPr lang="pt-BR" sz="1400" dirty="0">
+                <a:solidFill>
+                  <a:srgbClr val="000000"/>
+                </a:solidFill>
+                <a:latin typeface="Aptos"/>
+              </a:rPr>
+              <a:t>;</a:t>
+            </a:r>
+          </a:p>
+          <a:p>
+            <a:pPr marL="285750" indent="-285750" algn="just">
+              <a:buFont typeface="Wingdings" panose="05000000000000000000" pitchFamily="2" charset="2"/>
+              <a:buChar char="q"/>
+            </a:pPr>
+            <a:r>
+              <a:rPr lang="pt-BR" sz="1400" dirty="0">
+                <a:solidFill>
+                  <a:srgbClr val="000000"/>
+                </a:solidFill>
+                <a:latin typeface="Aptos"/>
+              </a:rPr>
+              <a:t>A abertura mecânica do disjuntor foi confirmada em 16:06:10.879, correspondendo a 62ms. </a:t>
+            </a:r>
+          </a:p>
+          <a:p>
+            <a:pPr marL="285750" indent="-285750" algn="just">
+              <a:buFont typeface="Wingdings" panose="05000000000000000000" pitchFamily="2" charset="2"/>
+              <a:buChar char="q"/>
+            </a:pPr>
+            <a:r>
+              <a:rPr lang="pt-BR" sz="1400" dirty="0">
+                <a:solidFill>
+                  <a:srgbClr val="000000"/>
+                </a:solidFill>
+                <a:latin typeface="Aptos"/>
+              </a:rPr>
+              <a:t>O localizador de falta apontou distancia estimada de 61.01 km;</a:t>
+            </a:r>
+          </a:p>
+          <a:p>
+            <a:pPr marL="285750" indent="-285750" algn="just">
+              <a:buFont typeface="Wingdings" panose="05000000000000000000" pitchFamily="2" charset="2"/>
+              <a:buChar char="q"/>
+            </a:pPr>
+            <a:r>
+              <a:rPr lang="pt-BR" sz="1400" b="1" dirty="0">
+                <a:solidFill>
+                  <a:srgbClr val="000000"/>
+                </a:solidFill>
+                <a:latin typeface="Aptos"/>
+              </a:rPr>
+              <a:t>CONCLUSÃO:</a:t>
+            </a:r>
+            <a:r>
+              <a:rPr lang="pt-BR" sz="1400" dirty="0">
+                <a:solidFill>
+                  <a:srgbClr val="000000"/>
+                </a:solidFill>
+                <a:latin typeface="Aptos"/>
+              </a:rPr>
+              <a:t> A atuação foi satisfatória diante do defeito apresentado.</a:t>
+            </a:r>
+            <a:endParaRPr lang="pt-BR" sz="1800" dirty="0">
               <a:solidFill>
                 <a:schemeClr val="bg1"/>
               </a:solidFill>
@@ -4685,7 +4769,7 @@
                 </a:solidFill>
                 <a:latin typeface="Aptos" panose="020B0004020202020204" pitchFamily="34" charset="0"/>
               </a:rPr>
-              <a:t>DESLIGAMENTO DO DJ BBBB  NO DIA XX/YY/ZZZZ </a:t>
+              <a:t>DESLIGAMENTO DO DJ AAA BBBB  NO DIA XX/YY/ZZZZ </a:t>
             </a:r>
             <a:r>
               <a:rPr kumimoji="0" lang="pt-BR" sz="2000" b="1" i="0" u="none" strike="noStrike" kern="0" cap="none" spc="0" normalizeH="0" baseline="0" noProof="0" dirty="0">
@@ -5688,6 +5772,26 @@
 </file>
 
 <file path=customXml/item1.xml><?xml version="1.0" encoding="utf-8"?>
+<?mso-contentType ?>
+<FormTemplates xmlns="http://schemas.microsoft.com/sharepoint/v3/contenttype/forms">
+  <Display>DocumentLibraryForm</Display>
+  <Edit>DocumentLibraryForm</Edit>
+  <New>DocumentLibraryForm</New>
+</FormTemplates>
+</file>
+
+<file path=customXml/item2.xml><?xml version="1.0" encoding="utf-8"?>
+<p:properties xmlns:p="http://schemas.microsoft.com/office/2006/metadata/properties" xmlns:xsi="http://www.w3.org/2001/XMLSchema-instance" xmlns:pc="http://schemas.microsoft.com/office/infopath/2007/PartnerControls">
+  <documentManagement>
+    <TaxCatchAll xmlns="8049805f-ae2a-45c2-83a4-29bcb954d2c0" xsi:nil="true"/>
+    <lcf76f155ced4ddcb4097134ff3c332f xmlns="77e27ab2-cf69-4632-b9d5-05b2cd20ede9">
+      <Terms xmlns="http://schemas.microsoft.com/office/infopath/2007/PartnerControls"/>
+    </lcf76f155ced4ddcb4097134ff3c332f>
+  </documentManagement>
+</p:properties>
+</file>
+
+<file path=customXml/item3.xml><?xml version="1.0" encoding="utf-8"?>
 <ct:contentTypeSchema xmlns:ct="http://schemas.microsoft.com/office/2006/metadata/contentType" xmlns:ma="http://schemas.microsoft.com/office/2006/metadata/properties/metaAttributes" ct:_="" ma:_="" ma:contentTypeName="Documento" ma:contentTypeID="0x0101004EE1501F03CA3A469B1571C266769B39" ma:contentTypeVersion="15" ma:contentTypeDescription="Crie um novo documento." ma:contentTypeScope="" ma:versionID="c4b7b1ae47ef9ebd32309cc4bfc9afc3">
   <xsd:schema xmlns:xsd="http://www.w3.org/2001/XMLSchema" xmlns:xs="http://www.w3.org/2001/XMLSchema" xmlns:p="http://schemas.microsoft.com/office/2006/metadata/properties" xmlns:ns2="77e27ab2-cf69-4632-b9d5-05b2cd20ede9" xmlns:ns3="8049805f-ae2a-45c2-83a4-29bcb954d2c0" targetNamespace="http://schemas.microsoft.com/office/2006/metadata/properties" ma:root="true" ma:fieldsID="db64c2135ec15c3d405261ca442d99da" ns2:_="" ns3:_="">
     <xsd:import namespace="77e27ab2-cf69-4632-b9d5-05b2cd20ede9"/>
@@ -5922,41 +6026,10 @@
 </ct:contentTypeSchema>
 </file>
 
-<file path=customXml/item2.xml><?xml version="1.0" encoding="utf-8"?>
-<p:properties xmlns:p="http://schemas.microsoft.com/office/2006/metadata/properties" xmlns:xsi="http://www.w3.org/2001/XMLSchema-instance" xmlns:pc="http://schemas.microsoft.com/office/infopath/2007/PartnerControls">
-  <documentManagement>
-    <TaxCatchAll xmlns="8049805f-ae2a-45c2-83a4-29bcb954d2c0" xsi:nil="true"/>
-    <lcf76f155ced4ddcb4097134ff3c332f xmlns="77e27ab2-cf69-4632-b9d5-05b2cd20ede9">
-      <Terms xmlns="http://schemas.microsoft.com/office/infopath/2007/PartnerControls"/>
-    </lcf76f155ced4ddcb4097134ff3c332f>
-  </documentManagement>
-</p:properties>
-</file>
-
-<file path=customXml/item3.xml><?xml version="1.0" encoding="utf-8"?>
-<?mso-contentType ?>
-<FormTemplates xmlns="http://schemas.microsoft.com/sharepoint/v3/contenttype/forms">
-  <Display>DocumentLibraryForm</Display>
-  <Edit>DocumentLibraryForm</Edit>
-  <New>DocumentLibraryForm</New>
-</FormTemplates>
-</file>
-
 <file path=customXml/itemProps1.xml><?xml version="1.0" encoding="utf-8"?>
-<ds:datastoreItem xmlns:ds="http://schemas.openxmlformats.org/officeDocument/2006/customXml" ds:itemID="{049B3DD0-7D0E-4515-BAF2-414E17542338}">
+<ds:datastoreItem xmlns:ds="http://schemas.openxmlformats.org/officeDocument/2006/customXml" ds:itemID="{B125705C-883B-4893-B158-9444686A6F58}">
   <ds:schemaRefs>
-    <ds:schemaRef ds:uri="77e27ab2-cf69-4632-b9d5-05b2cd20ede9"/>
-    <ds:schemaRef ds:uri="8049805f-ae2a-45c2-83a4-29bcb954d2c0"/>
-    <ds:schemaRef ds:uri="http://purl.org/dc/elements/1.1/"/>
-    <ds:schemaRef ds:uri="http://purl.org/dc/terms/"/>
-    <ds:schemaRef ds:uri="http://schemas.microsoft.com/internal/obd"/>
-    <ds:schemaRef ds:uri="http://schemas.microsoft.com/office/2006/documentManagement/types"/>
-    <ds:schemaRef ds:uri="http://schemas.microsoft.com/office/2006/metadata/contentType"/>
-    <ds:schemaRef ds:uri="http://schemas.microsoft.com/office/2006/metadata/properties"/>
-    <ds:schemaRef ds:uri="http://schemas.microsoft.com/office/2006/metadata/properties/metaAttributes"/>
-    <ds:schemaRef ds:uri="http://schemas.microsoft.com/office/infopath/2007/PartnerControls"/>
-    <ds:schemaRef ds:uri="http://schemas.openxmlformats.org/package/2006/metadata/core-properties"/>
-    <ds:schemaRef ds:uri="http://www.w3.org/2001/XMLSchema"/>
+    <ds:schemaRef ds:uri="http://schemas.microsoft.com/sharepoint/v3/contenttype/forms"/>
   </ds:schemaRefs>
 </ds:datastoreItem>
 </file>
@@ -5979,9 +6052,20 @@
 </file>
 
 <file path=customXml/itemProps3.xml><?xml version="1.0" encoding="utf-8"?>
-<ds:datastoreItem xmlns:ds="http://schemas.openxmlformats.org/officeDocument/2006/customXml" ds:itemID="{B125705C-883B-4893-B158-9444686A6F58}">
+<ds:datastoreItem xmlns:ds="http://schemas.openxmlformats.org/officeDocument/2006/customXml" ds:itemID="{049B3DD0-7D0E-4515-BAF2-414E17542338}">
   <ds:schemaRefs>
-    <ds:schemaRef ds:uri="http://schemas.microsoft.com/sharepoint/v3/contenttype/forms"/>
+    <ds:schemaRef ds:uri="77e27ab2-cf69-4632-b9d5-05b2cd20ede9"/>
+    <ds:schemaRef ds:uri="8049805f-ae2a-45c2-83a4-29bcb954d2c0"/>
+    <ds:schemaRef ds:uri="http://purl.org/dc/elements/1.1/"/>
+    <ds:schemaRef ds:uri="http://purl.org/dc/terms/"/>
+    <ds:schemaRef ds:uri="http://schemas.microsoft.com/internal/obd"/>
+    <ds:schemaRef ds:uri="http://schemas.microsoft.com/office/2006/documentManagement/types"/>
+    <ds:schemaRef ds:uri="http://schemas.microsoft.com/office/2006/metadata/contentType"/>
+    <ds:schemaRef ds:uri="http://schemas.microsoft.com/office/2006/metadata/properties"/>
+    <ds:schemaRef ds:uri="http://schemas.microsoft.com/office/2006/metadata/properties/metaAttributes"/>
+    <ds:schemaRef ds:uri="http://schemas.microsoft.com/office/infopath/2007/PartnerControls"/>
+    <ds:schemaRef ds:uri="http://schemas.openxmlformats.org/package/2006/metadata/core-properties"/>
+    <ds:schemaRef ds:uri="http://www.w3.org/2001/XMLSchema"/>
   </ds:schemaRefs>
 </ds:datastoreItem>
 </file>
</xml_diff>